<commit_message>
update solutions and slides
</commit_message>
<xml_diff>
--- a/topic06-arrays/unit-1/talk-2-array-classes/b-array-classes.pptx
+++ b/topic06-arrays/unit-1/talk-2-array-classes/b-array-classes.pptx
@@ -5,7 +5,7 @@
     <p:sldMasterId id="2147483660" r:id="rId1"/>
   </p:sldMasterIdLst>
   <p:notesMasterIdLst>
-    <p:notesMasterId r:id="rId29"/>
+    <p:notesMasterId r:id="rId30"/>
   </p:notesMasterIdLst>
   <p:sldIdLst>
     <p:sldId id="325" r:id="rId2"/>
@@ -34,7 +34,8 @@
     <p:sldId id="641" r:id="rId25"/>
     <p:sldId id="642" r:id="rId26"/>
     <p:sldId id="634" r:id="rId27"/>
-    <p:sldId id="347" r:id="rId28"/>
+    <p:sldId id="657" r:id="rId28"/>
+    <p:sldId id="347" r:id="rId29"/>
   </p:sldIdLst>
   <p:sldSz cx="12192000" cy="6858000"/>
   <p:notesSz cx="6858000" cy="9144000"/>
@@ -234,7 +235,7 @@
           <a:p>
             <a:fld id="{58C3D141-1E1C-433C-AD3A-CD56CBBB4F9F}" type="datetimeFigureOut">
               <a:rPr lang="en-IE" smtClean="0"/>
-              <a:t>19/10/2025</a:t>
+              <a:t>21/10/2025</a:t>
             </a:fld>
             <a:endParaRPr lang="en-IE"/>
           </a:p>
@@ -8088,7 +8089,7 @@
             <a:fld id="{1D8BD707-D9CF-40AE-B4C6-C98DA3205C09}" type="datetimeFigureOut">
               <a:rPr lang="en-US" smtClean="0"/>
               <a:pPr/>
-              <a:t>10/19/25</a:t>
+              <a:t>10/21/25</a:t>
             </a:fld>
             <a:endParaRPr lang="en-US"/>
           </a:p>
@@ -8260,7 +8261,7 @@
             <a:fld id="{1D8BD707-D9CF-40AE-B4C6-C98DA3205C09}" type="datetimeFigureOut">
               <a:rPr lang="en-US" smtClean="0"/>
               <a:pPr/>
-              <a:t>10/19/25</a:t>
+              <a:t>10/21/25</a:t>
             </a:fld>
             <a:endParaRPr lang="en-US"/>
           </a:p>
@@ -8442,7 +8443,7 @@
             <a:fld id="{1D8BD707-D9CF-40AE-B4C6-C98DA3205C09}" type="datetimeFigureOut">
               <a:rPr lang="en-US" smtClean="0"/>
               <a:pPr/>
-              <a:t>10/19/25</a:t>
+              <a:t>10/21/25</a:t>
             </a:fld>
             <a:endParaRPr lang="en-US"/>
           </a:p>
@@ -9175,7 +9176,7 @@
             <a:fld id="{1D8BD707-D9CF-40AE-B4C6-C98DA3205C09}" type="datetimeFigureOut">
               <a:rPr lang="en-US" smtClean="0"/>
               <a:pPr/>
-              <a:t>10/19/25</a:t>
+              <a:t>10/21/25</a:t>
             </a:fld>
             <a:endParaRPr lang="en-US"/>
           </a:p>
@@ -9637,7 +9638,7 @@
             <a:fld id="{1D8BD707-D9CF-40AE-B4C6-C98DA3205C09}" type="datetimeFigureOut">
               <a:rPr lang="en-US" smtClean="0"/>
               <a:pPr/>
-              <a:t>10/19/25</a:t>
+              <a:t>10/21/25</a:t>
             </a:fld>
             <a:endParaRPr lang="en-US"/>
           </a:p>
@@ -9938,7 +9939,7 @@
             <a:fld id="{1D8BD707-D9CF-40AE-B4C6-C98DA3205C09}" type="datetimeFigureOut">
               <a:rPr lang="en-US" smtClean="0"/>
               <a:pPr/>
-              <a:t>10/19/25</a:t>
+              <a:t>10/21/25</a:t>
             </a:fld>
             <a:endParaRPr lang="en-US"/>
           </a:p>
@@ -10568,7 +10569,7 @@
             <a:fld id="{1D8BD707-D9CF-40AE-B4C6-C98DA3205C09}" type="datetimeFigureOut">
               <a:rPr lang="en-US" smtClean="0"/>
               <a:pPr/>
-              <a:t>10/19/25</a:t>
+              <a:t>10/21/25</a:t>
             </a:fld>
             <a:endParaRPr lang="en-US"/>
           </a:p>
@@ -10857,7 +10858,7 @@
             <a:fld id="{1D8BD707-D9CF-40AE-B4C6-C98DA3205C09}" type="datetimeFigureOut">
               <a:rPr lang="en-US" smtClean="0"/>
               <a:pPr/>
-              <a:t>10/19/25</a:t>
+              <a:t>10/21/25</a:t>
             </a:fld>
             <a:endParaRPr lang="en-US"/>
           </a:p>
@@ -11153,7 +11154,7 @@
             <a:fld id="{1D8BD707-D9CF-40AE-B4C6-C98DA3205C09}" type="datetimeFigureOut">
               <a:rPr lang="en-US" smtClean="0"/>
               <a:pPr/>
-              <a:t>10/19/25</a:t>
+              <a:t>10/21/25</a:t>
             </a:fld>
             <a:endParaRPr lang="en-US"/>
           </a:p>
@@ -11432,7 +11433,7 @@
             <a:fld id="{1D8BD707-D9CF-40AE-B4C6-C98DA3205C09}" type="datetimeFigureOut">
               <a:rPr lang="en-US" smtClean="0"/>
               <a:pPr/>
-              <a:t>10/19/25</a:t>
+              <a:t>10/21/25</a:t>
             </a:fld>
             <a:endParaRPr lang="en-US"/>
           </a:p>
@@ -11691,7 +11692,7 @@
             <a:fld id="{1D8BD707-D9CF-40AE-B4C6-C98DA3205C09}" type="datetimeFigureOut">
               <a:rPr lang="en-US" smtClean="0"/>
               <a:pPr/>
-              <a:t>10/19/25</a:t>
+              <a:t>10/21/25</a:t>
             </a:fld>
             <a:endParaRPr lang="en-US"/>
           </a:p>
@@ -11911,7 +11912,7 @@
             <a:fld id="{1D8BD707-D9CF-40AE-B4C6-C98DA3205C09}" type="datetimeFigureOut">
               <a:rPr lang="en-US" smtClean="0"/>
               <a:pPr/>
-              <a:t>10/19/25</a:t>
+              <a:t>10/21/25</a:t>
             </a:fld>
             <a:endParaRPr lang="en-US"/>
           </a:p>
@@ -23835,6 +23836,16 @@
 <file path=ppt/slides/slide25.xml><?xml version="1.0" encoding="utf-8"?>
 <p:sld xmlns:a="http://schemas.openxmlformats.org/drawingml/2006/main" xmlns:r="http://schemas.openxmlformats.org/officeDocument/2006/relationships" xmlns:p="http://schemas.openxmlformats.org/presentationml/2006/main">
   <p:cSld>
+    <p:bg>
+      <p:bgPr>
+        <a:solidFill>
+          <a:schemeClr val="bg1">
+            <a:lumMod val="85000"/>
+          </a:schemeClr>
+        </a:solidFill>
+        <a:effectLst/>
+      </p:bgPr>
+    </p:bg>
     <p:spTree>
       <p:nvGrpSpPr>
         <p:cNvPr id="1" name=""/>
@@ -24782,7 +24793,7 @@
           <p:nvPr/>
         </p:nvPicPr>
         <p:blipFill>
-          <a:blip r:embed="rId3"/>
+          <a:blip r:embed="rId4"/>
           <a:stretch>
             <a:fillRect/>
           </a:stretch>
@@ -24805,7 +24816,7 @@
     </p:extLst>
   </p:cSld>
   <p:clrMapOvr>
-    <a:masterClrMapping/>
+    <a:overrideClrMapping bg1="lt1" tx1="dk1" bg2="lt2" tx2="dk2" accent1="accent1" accent2="accent2" accent3="accent3" accent4="accent4" accent5="accent5" accent6="accent6" hlink="hlink" folHlink="folHlink"/>
   </p:clrMapOvr>
   <p:timing>
     <p:tnLst>
@@ -25140,12 +25151,35 @@
         </p:nvSpPr>
         <p:spPr bwMode="auto">
           <a:xfrm>
-            <a:off x="2157473" y="1488195"/>
-            <a:ext cx="8001000" cy="4524315"/>
+            <a:off x="2157473" y="1857526"/>
+            <a:ext cx="8001000" cy="3785652"/>
           </a:xfrm>
           <a:prstGeom prst="rect">
             <a:avLst/>
           </a:prstGeom>
+          <a:gradFill>
+            <a:gsLst>
+              <a:gs pos="0">
+                <a:schemeClr val="accent1">
+                  <a:tint val="50000"/>
+                  <a:satMod val="300000"/>
+                </a:schemeClr>
+              </a:gs>
+              <a:gs pos="35000">
+                <a:schemeClr val="accent1">
+                  <a:tint val="37000"/>
+                  <a:satMod val="300000"/>
+                </a:schemeClr>
+              </a:gs>
+              <a:gs pos="100000">
+                <a:schemeClr val="accent1">
+                  <a:tint val="15000"/>
+                  <a:satMod val="350000"/>
+                </a:schemeClr>
+              </a:gs>
+            </a:gsLst>
+            <a:lin ang="16200000" scaled="1"/>
+          </a:gradFill>
           <a:ln/>
         </p:spPr>
         <p:style>
@@ -25189,22 +25223,22 @@
               <a:t>public </a:t>
             </a:r>
             <a:r>
-              <a:rPr lang="en-VI" altLang="en-VI" sz="2400" dirty="0">
+              <a:rPr lang="en-029" altLang="en-VI" sz="2400" dirty="0">
                 <a:solidFill>
                   <a:srgbClr val="000000"/>
                 </a:solidFill>
                 <a:latin typeface="JetBrains Mono"/>
               </a:rPr>
-              <a:t>String </a:t>
-            </a:r>
-            <a:r>
-              <a:rPr lang="en-VI" altLang="en-VI" sz="2400" dirty="0" err="1">
-                <a:solidFill>
-                  <a:srgbClr val="00627A"/>
+              <a:t>void</a:t>
+            </a:r>
+            <a:r>
+              <a:rPr lang="en-VI" altLang="en-VI" sz="2400" dirty="0">
+                <a:solidFill>
+                  <a:srgbClr val="000000"/>
                 </a:solidFill>
                 <a:latin typeface="JetBrains Mono"/>
               </a:rPr>
-              <a:t>list</a:t>
+              <a:t> </a:t>
             </a:r>
             <a:r>
               <a:rPr lang="en-029" altLang="en-VI" sz="2400" dirty="0" err="1">
@@ -25213,7 +25247,7 @@
                 </a:solidFill>
                 <a:latin typeface="JetBrains Mono"/>
               </a:rPr>
-              <a:t>Friends</a:t>
+              <a:t>printFriends</a:t>
             </a:r>
             <a:r>
               <a:rPr lang="en-VI" altLang="en-VI" sz="2400" dirty="0">
@@ -25240,6 +25274,42 @@
                 <a:spcPct val="0"/>
               </a:spcAft>
             </a:pPr>
+            <a:r>
+              <a:rPr lang="en-029" altLang="en-VI" sz="2400" dirty="0">
+                <a:solidFill>
+                  <a:srgbClr val="0033B3"/>
+                </a:solidFill>
+                <a:latin typeface="JetBrains Mono"/>
+              </a:rPr>
+              <a:t>        if  </a:t>
+            </a:r>
+            <a:r>
+              <a:rPr lang="en-029" altLang="en-VI" sz="2400" dirty="0">
+                <a:solidFill>
+                  <a:srgbClr val="080808"/>
+                </a:solidFill>
+                <a:latin typeface="JetBrains Mono"/>
+              </a:rPr>
+              <a:t>(size == 0 ) </a:t>
+            </a:r>
+            <a:r>
+              <a:rPr lang="en-029" altLang="en-VI" sz="2400" dirty="0">
+                <a:solidFill>
+                  <a:srgbClr val="0033B3"/>
+                </a:solidFill>
+                <a:latin typeface="JetBrains Mono"/>
+              </a:rPr>
+              <a:t>return</a:t>
+            </a:r>
+            <a:r>
+              <a:rPr lang="en-029" altLang="en-VI" sz="2400" dirty="0">
+                <a:solidFill>
+                  <a:srgbClr val="080808"/>
+                </a:solidFill>
+                <a:latin typeface="JetBrains Mono"/>
+              </a:rPr>
+              <a:t> “Sorry no Friends”;</a:t>
+            </a:r>
             <a:br>
               <a:rPr lang="en-VI" altLang="en-VI" sz="2400" dirty="0">
                 <a:solidFill>
@@ -25249,7 +25319,7 @@
               </a:rPr>
             </a:br>
             <a:r>
-              <a:rPr lang="en-VI" altLang="en-VI" sz="2400" dirty="0">
+              <a:rPr lang="en-029" altLang="en-VI" sz="2400" dirty="0">
                 <a:solidFill>
                   <a:srgbClr val="080808"/>
                 </a:solidFill>
@@ -25257,32 +25327,113 @@
               </a:rPr>
               <a:t>        </a:t>
             </a:r>
-            <a:r>
-              <a:rPr lang="en-VI" altLang="en-VI" sz="2400" dirty="0">
-                <a:solidFill>
-                  <a:srgbClr val="000000"/>
+          </a:p>
+          <a:p>
+            <a:pPr eaLnBrk="0" fontAlgn="base" hangingPunct="0">
+              <a:spcBef>
+                <a:spcPct val="0"/>
+              </a:spcBef>
+              <a:spcAft>
+                <a:spcPct val="0"/>
+              </a:spcAft>
+            </a:pPr>
+            <a:r>
+              <a:rPr lang="en-029" altLang="en-VI" sz="2400" dirty="0">
+                <a:solidFill>
+                  <a:srgbClr val="080808"/>
                 </a:solidFill>
                 <a:latin typeface="JetBrains Mono"/>
               </a:rPr>
-              <a:t>String </a:t>
-            </a:r>
-            <a:r>
-              <a:rPr lang="en-VI" altLang="en-VI" sz="2400" dirty="0" err="1">
-                <a:solidFill>
-                  <a:srgbClr val="080808"/>
+              <a:t>         </a:t>
+            </a:r>
+            <a:r>
+              <a:rPr lang="en-029" altLang="en-VI" sz="2400" dirty="0">
+                <a:solidFill>
+                  <a:srgbClr val="0033B3"/>
                 </a:solidFill>
                 <a:latin typeface="JetBrains Mono"/>
               </a:rPr>
-              <a:t>listOf</a:t>
-            </a:r>
-            <a:r>
-              <a:rPr lang="en-029" altLang="en-VI" sz="2400" dirty="0" err="1">
+              <a:t>else</a:t>
+            </a:r>
+            <a:r>
+              <a:rPr lang="en-029" altLang="en-VI" sz="2400" dirty="0">
                 <a:solidFill>
                   <a:srgbClr val="080808"/>
                 </a:solidFill>
                 <a:latin typeface="JetBrains Mono"/>
               </a:rPr>
-              <a:t>Friends</a:t>
+              <a:t> { </a:t>
+            </a:r>
+            <a:br>
+              <a:rPr lang="en-VI" altLang="en-VI" sz="2400" dirty="0">
+                <a:solidFill>
+                  <a:srgbClr val="080808"/>
+                </a:solidFill>
+                <a:latin typeface="JetBrains Mono"/>
+              </a:rPr>
+            </a:br>
+            <a:r>
+              <a:rPr lang="en-VI" altLang="en-VI" sz="2400" dirty="0">
+                <a:solidFill>
+                  <a:srgbClr val="080808"/>
+                </a:solidFill>
+                <a:latin typeface="JetBrains Mono"/>
+              </a:rPr>
+              <a:t>       </a:t>
+            </a:r>
+            <a:r>
+              <a:rPr lang="en-029" altLang="en-VI" sz="2400" dirty="0">
+                <a:solidFill>
+                  <a:srgbClr val="080808"/>
+                </a:solidFill>
+                <a:latin typeface="JetBrains Mono"/>
+              </a:rPr>
+              <a:t>        </a:t>
+            </a:r>
+            <a:r>
+              <a:rPr lang="en-VI" altLang="en-VI" sz="2400" dirty="0">
+                <a:solidFill>
+                  <a:srgbClr val="080808"/>
+                </a:solidFill>
+                <a:latin typeface="JetBrains Mono"/>
+              </a:rPr>
+              <a:t> </a:t>
+            </a:r>
+            <a:r>
+              <a:rPr lang="en-VI" altLang="en-VI" sz="2400" dirty="0">
+                <a:solidFill>
+                  <a:srgbClr val="0033B3"/>
+                </a:solidFill>
+                <a:latin typeface="JetBrains Mono"/>
+              </a:rPr>
+              <a:t>for </a:t>
+            </a:r>
+            <a:r>
+              <a:rPr lang="en-VI" altLang="en-VI" sz="2400" dirty="0">
+                <a:solidFill>
+                  <a:srgbClr val="080808"/>
+                </a:solidFill>
+                <a:latin typeface="JetBrains Mono"/>
+              </a:rPr>
+              <a:t>(</a:t>
+            </a:r>
+            <a:r>
+              <a:rPr lang="en-VI" altLang="en-VI" sz="2400" dirty="0">
+                <a:solidFill>
+                  <a:srgbClr val="0033B3"/>
+                </a:solidFill>
+                <a:latin typeface="JetBrains Mono"/>
+              </a:rPr>
+              <a:t>int </a:t>
+            </a:r>
+            <a:r>
+              <a:rPr lang="en-VI" altLang="en-VI" sz="2400" dirty="0" err="1">
+                <a:solidFill>
+                  <a:srgbClr val="080808"/>
+                </a:solidFill>
+                <a:latin typeface="JetBrains Mono"/>
+              </a:rPr>
+              <a:t>i</a:t>
             </a:r>
             <a:r>
               <a:rPr lang="en-VI" altLang="en-VI" sz="2400" dirty="0">
@@ -25296,11 +25447,11 @@
             <a:r>
               <a:rPr lang="en-VI" altLang="en-VI" sz="2400" dirty="0">
                 <a:solidFill>
-                  <a:srgbClr val="067D17"/>
+                  <a:srgbClr val="1750EB"/>
                 </a:solidFill>
                 <a:latin typeface="JetBrains Mono"/>
               </a:rPr>
-              <a:t>""</a:t>
+              <a:t>0</a:t>
             </a:r>
             <a:r>
               <a:rPr lang="en-VI" altLang="en-VI" sz="2400" dirty="0">
@@ -25309,7 +25460,213 @@
                 </a:solidFill>
                 <a:latin typeface="JetBrains Mono"/>
               </a:rPr>
-              <a:t>;</a:t>
+              <a:t>; </a:t>
+            </a:r>
+            <a:r>
+              <a:rPr lang="en-VI" altLang="en-VI" sz="2400" dirty="0" err="1">
+                <a:solidFill>
+                  <a:srgbClr val="080808"/>
+                </a:solidFill>
+                <a:latin typeface="JetBrains Mono"/>
+              </a:rPr>
+              <a:t>i</a:t>
+            </a:r>
+            <a:r>
+              <a:rPr lang="en-VI" altLang="en-VI" sz="2400" dirty="0">
+                <a:solidFill>
+                  <a:srgbClr val="080808"/>
+                </a:solidFill>
+                <a:latin typeface="JetBrains Mono"/>
+              </a:rPr>
+              <a:t> &lt; </a:t>
+            </a:r>
+            <a:r>
+              <a:rPr lang="en-GB" altLang="en-VI" sz="2400" dirty="0" err="1">
+                <a:solidFill>
+                  <a:srgbClr val="871094"/>
+                </a:solidFill>
+                <a:latin typeface="JetBrains Mono"/>
+              </a:rPr>
+              <a:t>friends.length</a:t>
+            </a:r>
+            <a:r>
+              <a:rPr lang="en-VI" altLang="en-VI" sz="2400" dirty="0">
+                <a:solidFill>
+                  <a:srgbClr val="080808"/>
+                </a:solidFill>
+                <a:latin typeface="JetBrains Mono"/>
+              </a:rPr>
+              <a:t>; </a:t>
+            </a:r>
+            <a:r>
+              <a:rPr lang="en-VI" altLang="en-VI" sz="2400" dirty="0" err="1">
+                <a:solidFill>
+                  <a:srgbClr val="080808"/>
+                </a:solidFill>
+                <a:latin typeface="JetBrains Mono"/>
+              </a:rPr>
+              <a:t>i</a:t>
+            </a:r>
+            <a:r>
+              <a:rPr lang="en-VI" altLang="en-VI" sz="2400" dirty="0">
+                <a:solidFill>
+                  <a:srgbClr val="080808"/>
+                </a:solidFill>
+                <a:latin typeface="JetBrains Mono"/>
+              </a:rPr>
+              <a:t>++) {</a:t>
+            </a:r>
+            <a:br>
+              <a:rPr lang="en-VI" altLang="en-VI" sz="2400" dirty="0">
+                <a:solidFill>
+                  <a:srgbClr val="080808"/>
+                </a:solidFill>
+                <a:latin typeface="JetBrains Mono"/>
+              </a:rPr>
+            </a:br>
+            <a:r>
+              <a:rPr lang="en-029" altLang="en-VI" sz="2400" dirty="0">
+                <a:solidFill>
+                  <a:srgbClr val="080808"/>
+                </a:solidFill>
+                <a:latin typeface="JetBrains Mono"/>
+              </a:rPr>
+              <a:t>	        friends[</a:t>
+            </a:r>
+            <a:r>
+              <a:rPr lang="en-029" altLang="en-VI" sz="2400" dirty="0" err="1">
+                <a:solidFill>
+                  <a:srgbClr val="080808"/>
+                </a:solidFill>
+                <a:latin typeface="JetBrains Mono"/>
+              </a:rPr>
+              <a:t>i</a:t>
+            </a:r>
+            <a:r>
+              <a:rPr lang="en-029" altLang="en-VI" sz="2400" dirty="0">
+                <a:solidFill>
+                  <a:srgbClr val="080808"/>
+                </a:solidFill>
+                <a:latin typeface="JetBrains Mono"/>
+              </a:rPr>
+              <a:t>]. </a:t>
+            </a:r>
+            <a:r>
+              <a:rPr lang="en-029" altLang="en-VI" sz="2400" dirty="0" err="1">
+                <a:solidFill>
+                  <a:srgbClr val="080808"/>
+                </a:solidFill>
+                <a:latin typeface="JetBrains Mono"/>
+              </a:rPr>
+              <a:t>printFirstName</a:t>
+            </a:r>
+            <a:r>
+              <a:rPr lang="en-029" altLang="en-VI" sz="2400" dirty="0">
+                <a:solidFill>
+                  <a:srgbClr val="080808"/>
+                </a:solidFill>
+                <a:latin typeface="JetBrains Mono"/>
+              </a:rPr>
+              <a:t>();</a:t>
+            </a:r>
+          </a:p>
+          <a:p>
+            <a:pPr eaLnBrk="0" fontAlgn="base" hangingPunct="0">
+              <a:spcBef>
+                <a:spcPct val="0"/>
+              </a:spcBef>
+              <a:spcAft>
+                <a:spcPct val="0"/>
+              </a:spcAft>
+            </a:pPr>
+            <a:r>
+              <a:rPr lang="en-IE" altLang="en-VI" sz="2400" dirty="0">
+                <a:solidFill>
+                  <a:srgbClr val="080808"/>
+                </a:solidFill>
+                <a:latin typeface="JetBrains Mono"/>
+              </a:rPr>
+              <a:t> 	        </a:t>
+            </a:r>
+            <a:r>
+              <a:rPr lang="en-029" altLang="en-VI" sz="2400" dirty="0">
+                <a:solidFill>
+                  <a:srgbClr val="080808"/>
+                </a:solidFill>
+                <a:latin typeface="JetBrains Mono"/>
+              </a:rPr>
+              <a:t>friends[</a:t>
+            </a:r>
+            <a:r>
+              <a:rPr lang="en-029" altLang="en-VI" sz="2400" dirty="0" err="1">
+                <a:solidFill>
+                  <a:srgbClr val="080808"/>
+                </a:solidFill>
+                <a:latin typeface="JetBrains Mono"/>
+              </a:rPr>
+              <a:t>i</a:t>
+            </a:r>
+            <a:r>
+              <a:rPr lang="en-029" altLang="en-VI" sz="2400" dirty="0">
+                <a:solidFill>
+                  <a:srgbClr val="080808"/>
+                </a:solidFill>
+                <a:latin typeface="JetBrains Mono"/>
+              </a:rPr>
+              <a:t>]. </a:t>
+            </a:r>
+            <a:r>
+              <a:rPr lang="en-029" altLang="en-VI" sz="2400" dirty="0" err="1">
+                <a:solidFill>
+                  <a:srgbClr val="080808"/>
+                </a:solidFill>
+                <a:latin typeface="JetBrains Mono"/>
+              </a:rPr>
+              <a:t>printSecondName</a:t>
+            </a:r>
+            <a:r>
+              <a:rPr lang="en-029" altLang="en-VI" sz="2400" dirty="0">
+                <a:solidFill>
+                  <a:srgbClr val="080808"/>
+                </a:solidFill>
+                <a:latin typeface="JetBrains Mono"/>
+              </a:rPr>
+              <a:t>();</a:t>
+            </a:r>
+            <a:br>
+              <a:rPr lang="en-VI" altLang="en-VI" sz="2400" dirty="0">
+                <a:solidFill>
+                  <a:srgbClr val="080808"/>
+                </a:solidFill>
+                <a:latin typeface="JetBrains Mono"/>
+              </a:rPr>
+            </a:br>
+            <a:r>
+              <a:rPr lang="en-VI" altLang="en-VI" sz="2400" dirty="0">
+                <a:solidFill>
+                  <a:srgbClr val="080808"/>
+                </a:solidFill>
+                <a:latin typeface="JetBrains Mono"/>
+              </a:rPr>
+              <a:t>        </a:t>
+            </a:r>
+            <a:r>
+              <a:rPr lang="en-029" altLang="en-VI" sz="2400" dirty="0">
+                <a:solidFill>
+                  <a:srgbClr val="080808"/>
+                </a:solidFill>
+                <a:latin typeface="JetBrains Mono"/>
+              </a:rPr>
+              <a:t>       </a:t>
+            </a:r>
+            <a:r>
+              <a:rPr lang="en-VI" altLang="en-VI" sz="2400" dirty="0">
+                <a:solidFill>
+                  <a:srgbClr val="080808"/>
+                </a:solidFill>
+                <a:latin typeface="JetBrains Mono"/>
+              </a:rPr>
+              <a:t>}</a:t>
             </a:r>
             <a:endParaRPr lang="en-GB" altLang="en-VI" sz="2400" dirty="0">
               <a:solidFill>
@@ -25327,14 +25684,15 @@
                 <a:spcPct val="0"/>
               </a:spcAft>
             </a:pPr>
-            <a:br>
-              <a:rPr lang="en-VI" altLang="en-VI" sz="2400" dirty="0">
+            <a:r>
+              <a:rPr lang="en-029" altLang="en-VI" sz="2400" dirty="0">
                 <a:solidFill>
                   <a:srgbClr val="080808"/>
                 </a:solidFill>
                 <a:latin typeface="JetBrains Mono"/>
               </a:rPr>
-            </a:br>
+              <a:t>          </a:t>
+            </a:r>
             <a:r>
               <a:rPr lang="en-VI" altLang="en-VI" sz="2400" dirty="0">
                 <a:solidFill>
@@ -25342,335 +25700,7 @@
                 </a:solidFill>
                 <a:latin typeface="JetBrains Mono"/>
               </a:rPr>
-              <a:t>        </a:t>
-            </a:r>
-            <a:r>
-              <a:rPr lang="en-VI" altLang="en-VI" sz="2400" dirty="0">
-                <a:solidFill>
-                  <a:srgbClr val="0033B3"/>
-                </a:solidFill>
-                <a:latin typeface="JetBrains Mono"/>
-              </a:rPr>
-              <a:t>for </a:t>
-            </a:r>
-            <a:r>
-              <a:rPr lang="en-VI" altLang="en-VI" sz="2400" dirty="0">
-                <a:solidFill>
-                  <a:srgbClr val="080808"/>
-                </a:solidFill>
-                <a:latin typeface="JetBrains Mono"/>
-              </a:rPr>
-              <a:t>(</a:t>
-            </a:r>
-            <a:r>
-              <a:rPr lang="en-VI" altLang="en-VI" sz="2400" dirty="0">
-                <a:solidFill>
-                  <a:srgbClr val="0033B3"/>
-                </a:solidFill>
-                <a:latin typeface="JetBrains Mono"/>
-              </a:rPr>
-              <a:t>int </a:t>
-            </a:r>
-            <a:r>
-              <a:rPr lang="en-VI" altLang="en-VI" sz="2400" dirty="0" err="1">
-                <a:solidFill>
-                  <a:srgbClr val="080808"/>
-                </a:solidFill>
-                <a:latin typeface="JetBrains Mono"/>
-              </a:rPr>
-              <a:t>i</a:t>
-            </a:r>
-            <a:r>
-              <a:rPr lang="en-VI" altLang="en-VI" sz="2400" dirty="0">
-                <a:solidFill>
-                  <a:srgbClr val="080808"/>
-                </a:solidFill>
-                <a:latin typeface="JetBrains Mono"/>
-              </a:rPr>
-              <a:t> = </a:t>
-            </a:r>
-            <a:r>
-              <a:rPr lang="en-VI" altLang="en-VI" sz="2400" dirty="0">
-                <a:solidFill>
-                  <a:srgbClr val="1750EB"/>
-                </a:solidFill>
-                <a:latin typeface="JetBrains Mono"/>
-              </a:rPr>
-              <a:t>0</a:t>
-            </a:r>
-            <a:r>
-              <a:rPr lang="en-VI" altLang="en-VI" sz="2400" dirty="0">
-                <a:solidFill>
-                  <a:srgbClr val="080808"/>
-                </a:solidFill>
-                <a:latin typeface="JetBrains Mono"/>
-              </a:rPr>
-              <a:t>; </a:t>
-            </a:r>
-            <a:r>
-              <a:rPr lang="en-VI" altLang="en-VI" sz="2400" dirty="0" err="1">
-                <a:solidFill>
-                  <a:srgbClr val="080808"/>
-                </a:solidFill>
-                <a:latin typeface="JetBrains Mono"/>
-              </a:rPr>
-              <a:t>i</a:t>
-            </a:r>
-            <a:r>
-              <a:rPr lang="en-VI" altLang="en-VI" sz="2400" dirty="0">
-                <a:solidFill>
-                  <a:srgbClr val="080808"/>
-                </a:solidFill>
-                <a:latin typeface="JetBrains Mono"/>
-              </a:rPr>
-              <a:t> &lt; </a:t>
-            </a:r>
-            <a:r>
-              <a:rPr lang="en-GB" altLang="en-VI" sz="2400" dirty="0" err="1">
-                <a:solidFill>
-                  <a:srgbClr val="871094"/>
-                </a:solidFill>
-                <a:latin typeface="JetBrains Mono"/>
-              </a:rPr>
-              <a:t>friends.length</a:t>
-            </a:r>
-            <a:r>
-              <a:rPr lang="en-VI" altLang="en-VI" sz="2400" dirty="0">
-                <a:solidFill>
-                  <a:srgbClr val="080808"/>
-                </a:solidFill>
-                <a:latin typeface="JetBrains Mono"/>
-              </a:rPr>
-              <a:t>; </a:t>
-            </a:r>
-            <a:r>
-              <a:rPr lang="en-VI" altLang="en-VI" sz="2400" dirty="0" err="1">
-                <a:solidFill>
-                  <a:srgbClr val="080808"/>
-                </a:solidFill>
-                <a:latin typeface="JetBrains Mono"/>
-              </a:rPr>
-              <a:t>i</a:t>
-            </a:r>
-            <a:r>
-              <a:rPr lang="en-VI" altLang="en-VI" sz="2400" dirty="0">
-                <a:solidFill>
-                  <a:srgbClr val="080808"/>
-                </a:solidFill>
-                <a:latin typeface="JetBrains Mono"/>
-              </a:rPr>
-              <a:t>++) {</a:t>
-            </a:r>
-            <a:br>
-              <a:rPr lang="en-VI" altLang="en-VI" sz="2400" dirty="0">
-                <a:solidFill>
-                  <a:srgbClr val="080808"/>
-                </a:solidFill>
-                <a:latin typeface="JetBrains Mono"/>
-              </a:rPr>
-            </a:br>
-            <a:r>
-              <a:rPr lang="en-029" altLang="en-VI" sz="2400" dirty="0">
-                <a:solidFill>
-                  <a:srgbClr val="080808"/>
-                </a:solidFill>
-                <a:latin typeface="JetBrains Mono"/>
-              </a:rPr>
-              <a:t>	friends[</a:t>
-            </a:r>
-            <a:r>
-              <a:rPr lang="en-029" altLang="en-VI" sz="2400" dirty="0" err="1">
-                <a:solidFill>
-                  <a:srgbClr val="080808"/>
-                </a:solidFill>
-                <a:latin typeface="JetBrains Mono"/>
-              </a:rPr>
-              <a:t>i</a:t>
-            </a:r>
-            <a:r>
-              <a:rPr lang="en-029" altLang="en-VI" sz="2400" dirty="0">
-                <a:solidFill>
-                  <a:srgbClr val="080808"/>
-                </a:solidFill>
-                <a:latin typeface="JetBrains Mono"/>
-              </a:rPr>
-              <a:t>]. </a:t>
-            </a:r>
-            <a:r>
-              <a:rPr lang="en-029" altLang="en-VI" sz="2400" dirty="0" err="1">
-                <a:solidFill>
-                  <a:srgbClr val="080808"/>
-                </a:solidFill>
-                <a:latin typeface="JetBrains Mono"/>
-              </a:rPr>
-              <a:t>printFirstName</a:t>
-            </a:r>
-            <a:r>
-              <a:rPr lang="en-029" altLang="en-VI" sz="2400" dirty="0">
-                <a:solidFill>
-                  <a:srgbClr val="080808"/>
-                </a:solidFill>
-                <a:latin typeface="JetBrains Mono"/>
-              </a:rPr>
-              <a:t>();</a:t>
-            </a:r>
-          </a:p>
-          <a:p>
-            <a:pPr eaLnBrk="0" fontAlgn="base" hangingPunct="0">
-              <a:spcBef>
-                <a:spcPct val="0"/>
-              </a:spcBef>
-              <a:spcAft>
-                <a:spcPct val="0"/>
-              </a:spcAft>
-            </a:pPr>
-            <a:r>
-              <a:rPr lang="en-IE" altLang="en-VI" sz="2400" dirty="0">
-                <a:solidFill>
-                  <a:srgbClr val="080808"/>
-                </a:solidFill>
-                <a:latin typeface="JetBrains Mono"/>
-              </a:rPr>
-              <a:t> 	</a:t>
-            </a:r>
-            <a:r>
-              <a:rPr lang="en-029" altLang="en-VI" sz="2400" dirty="0">
-                <a:solidFill>
-                  <a:srgbClr val="080808"/>
-                </a:solidFill>
-                <a:latin typeface="JetBrains Mono"/>
-              </a:rPr>
-              <a:t>friends[</a:t>
-            </a:r>
-            <a:r>
-              <a:rPr lang="en-029" altLang="en-VI" sz="2400" dirty="0" err="1">
-                <a:solidFill>
-                  <a:srgbClr val="080808"/>
-                </a:solidFill>
-                <a:latin typeface="JetBrains Mono"/>
-              </a:rPr>
-              <a:t>i</a:t>
-            </a:r>
-            <a:r>
-              <a:rPr lang="en-029" altLang="en-VI" sz="2400" dirty="0">
-                <a:solidFill>
-                  <a:srgbClr val="080808"/>
-                </a:solidFill>
-                <a:latin typeface="JetBrains Mono"/>
-              </a:rPr>
-              <a:t>]. </a:t>
-            </a:r>
-            <a:r>
-              <a:rPr lang="en-029" altLang="en-VI" sz="2400" dirty="0" err="1">
-                <a:solidFill>
-                  <a:srgbClr val="080808"/>
-                </a:solidFill>
-                <a:latin typeface="JetBrains Mono"/>
-              </a:rPr>
-              <a:t>printSecondName</a:t>
-            </a:r>
-            <a:r>
-              <a:rPr lang="en-029" altLang="en-VI" sz="2400" dirty="0">
-                <a:solidFill>
-                  <a:srgbClr val="080808"/>
-                </a:solidFill>
-                <a:latin typeface="JetBrains Mono"/>
-              </a:rPr>
-              <a:t>();</a:t>
-            </a:r>
-            <a:br>
-              <a:rPr lang="en-VI" altLang="en-VI" sz="2400" dirty="0">
-                <a:solidFill>
-                  <a:srgbClr val="080808"/>
-                </a:solidFill>
-                <a:latin typeface="JetBrains Mono"/>
-              </a:rPr>
-            </a:br>
-            <a:r>
-              <a:rPr lang="en-VI" altLang="en-VI" sz="2400" dirty="0">
-                <a:solidFill>
-                  <a:srgbClr val="080808"/>
-                </a:solidFill>
-                <a:latin typeface="JetBrains Mono"/>
-              </a:rPr>
-              <a:t>        }</a:t>
-            </a:r>
-            <a:endParaRPr lang="en-GB" altLang="en-VI" sz="2400" dirty="0">
-              <a:solidFill>
-                <a:srgbClr val="080808"/>
-              </a:solidFill>
-              <a:latin typeface="JetBrains Mono"/>
-            </a:endParaRPr>
-          </a:p>
-          <a:p>
-            <a:pPr eaLnBrk="0" fontAlgn="base" hangingPunct="0">
-              <a:spcBef>
-                <a:spcPct val="0"/>
-              </a:spcBef>
-              <a:spcAft>
-                <a:spcPct val="0"/>
-              </a:spcAft>
-            </a:pPr>
-            <a:br>
-              <a:rPr lang="en-VI" altLang="en-VI" sz="2400" dirty="0">
-                <a:solidFill>
-                  <a:srgbClr val="080808"/>
-                </a:solidFill>
-                <a:latin typeface="JetBrains Mono"/>
-              </a:rPr>
-            </a:br>
-            <a:r>
-              <a:rPr lang="en-VI" altLang="en-VI" sz="2400" dirty="0">
-                <a:solidFill>
-                  <a:srgbClr val="080808"/>
-                </a:solidFill>
-                <a:latin typeface="JetBrains Mono"/>
-              </a:rPr>
-              <a:t>        </a:t>
-            </a:r>
-            <a:r>
-              <a:rPr lang="en-VI" altLang="en-VI" sz="2400" dirty="0">
-                <a:solidFill>
-                  <a:srgbClr val="0033B3"/>
-                </a:solidFill>
-                <a:latin typeface="JetBrains Mono"/>
-              </a:rPr>
-              <a:t>return </a:t>
-            </a:r>
-            <a:r>
-              <a:rPr lang="en-VI" altLang="en-VI" sz="2400" dirty="0" err="1">
-                <a:solidFill>
-                  <a:srgbClr val="080808"/>
-                </a:solidFill>
-                <a:latin typeface="JetBrains Mono"/>
-              </a:rPr>
-              <a:t>listOfProducts</a:t>
-            </a:r>
-            <a:r>
-              <a:rPr lang="en-VI" altLang="en-VI" sz="2400" dirty="0">
-                <a:solidFill>
-                  <a:srgbClr val="080808"/>
-                </a:solidFill>
-                <a:latin typeface="JetBrains Mono"/>
-              </a:rPr>
-              <a:t>;</a:t>
-            </a:r>
-            <a:br>
-              <a:rPr lang="en-VI" altLang="en-VI" sz="2400" dirty="0">
-                <a:solidFill>
-                  <a:srgbClr val="080808"/>
-                </a:solidFill>
-                <a:latin typeface="JetBrains Mono"/>
-              </a:rPr>
-            </a:br>
-            <a:r>
-              <a:rPr lang="en-VI" altLang="en-VI" sz="2400" dirty="0">
-                <a:solidFill>
-                  <a:srgbClr val="080808"/>
-                </a:solidFill>
-                <a:latin typeface="JetBrains Mono"/>
-              </a:rPr>
-              <a:t>    }</a:t>
+              <a:t>}</a:t>
             </a:r>
             <a:br>
               <a:rPr lang="en-VI" altLang="en-VI" sz="2400" dirty="0">
@@ -25713,6 +25743,766 @@
         <p:spPr>
           <a:xfrm>
             <a:off x="1984651" y="6178754"/>
+            <a:ext cx="7971798" cy="400110"/>
+          </a:xfrm>
+          <a:prstGeom prst="rect">
+            <a:avLst/>
+          </a:prstGeom>
+        </p:spPr>
+        <p:style>
+          <a:lnRef idx="2">
+            <a:schemeClr val="accent4"/>
+          </a:lnRef>
+          <a:fillRef idx="1">
+            <a:schemeClr val="lt1"/>
+          </a:fillRef>
+          <a:effectRef idx="0">
+            <a:schemeClr val="accent4"/>
+          </a:effectRef>
+          <a:fontRef idx="minor">
+            <a:schemeClr val="dk1"/>
+          </a:fontRef>
+        </p:style>
+        <p:txBody>
+          <a:bodyPr wrap="none" rtlCol="0">
+            <a:spAutoFit/>
+          </a:bodyPr>
+          <a:lstStyle/>
+          <a:p>
+            <a:r>
+              <a:rPr lang="en-GB" sz="2000" dirty="0"/>
+              <a:t>Prints first  and second names of all friends  stored in the primitive array.  </a:t>
+            </a:r>
+            <a:endParaRPr lang="en-VI" sz="2000" dirty="0"/>
+          </a:p>
+        </p:txBody>
+      </p:sp>
+    </p:spTree>
+    <p:extLst>
+      <p:ext uri="{BB962C8B-B14F-4D97-AF65-F5344CB8AC3E}">
+        <p14:creationId xmlns:p14="http://schemas.microsoft.com/office/powerpoint/2010/main" val="825745404"/>
+      </p:ext>
+    </p:extLst>
+  </p:cSld>
+  <p:clrMapOvr>
+    <a:masterClrMapping/>
+  </p:clrMapOvr>
+</p:sld>
+</file>
+
+<file path=ppt/slides/slide27.xml><?xml version="1.0" encoding="utf-8"?>
+<p:sld xmlns:a="http://schemas.openxmlformats.org/drawingml/2006/main" xmlns:r="http://schemas.openxmlformats.org/officeDocument/2006/relationships" xmlns:p="http://schemas.openxmlformats.org/presentationml/2006/main">
+  <p:cSld>
+    <p:spTree>
+      <p:nvGrpSpPr>
+        <p:cNvPr id="1" name="">
+          <a:extLst>
+            <a:ext uri="{FF2B5EF4-FFF2-40B4-BE49-F238E27FC236}">
+              <a16:creationId xmlns:a16="http://schemas.microsoft.com/office/drawing/2014/main" id="{97ACA62A-DFEC-AD9C-433F-C97129F48BB9}"/>
+            </a:ext>
+          </a:extLst>
+        </p:cNvPr>
+        <p:cNvGrpSpPr/>
+        <p:nvPr/>
+      </p:nvGrpSpPr>
+      <p:grpSpPr>
+        <a:xfrm>
+          <a:off x="0" y="0"/>
+          <a:ext cx="0" cy="0"/>
+          <a:chOff x="0" y="0"/>
+          <a:chExt cx="0" cy="0"/>
+        </a:xfrm>
+      </p:grpSpPr>
+      <p:sp>
+        <p:nvSpPr>
+          <p:cNvPr id="2" name="Title 1">
+            <a:extLst>
+              <a:ext uri="{FF2B5EF4-FFF2-40B4-BE49-F238E27FC236}">
+                <a16:creationId xmlns:a16="http://schemas.microsoft.com/office/drawing/2014/main" id="{93F206BE-C046-EEDE-1365-A804FDB377F5}"/>
+              </a:ext>
+            </a:extLst>
+          </p:cNvPr>
+          <p:cNvSpPr>
+            <a:spLocks noGrp="1"/>
+          </p:cNvSpPr>
+          <p:nvPr>
+            <p:ph type="title"/>
+          </p:nvPr>
+        </p:nvSpPr>
+        <p:spPr/>
+        <p:txBody>
+          <a:bodyPr>
+            <a:normAutofit/>
+          </a:bodyPr>
+          <a:lstStyle/>
+          <a:p>
+            <a:pPr algn="ctr"/>
+            <a:r>
+              <a:rPr lang="en-IE" dirty="0"/>
+              <a:t>Example using a </a:t>
+            </a:r>
+            <a:r>
+              <a:rPr lang="en-IE" b="1" dirty="0">
+                <a:solidFill>
+                  <a:srgbClr val="FF0000"/>
+                </a:solidFill>
+              </a:rPr>
+              <a:t>Person </a:t>
+            </a:r>
+            <a:r>
+              <a:rPr lang="en-IE" dirty="0"/>
+              <a:t>object array</a:t>
+            </a:r>
+            <a:endParaRPr lang="en-IE" b="1" dirty="0"/>
+          </a:p>
+        </p:txBody>
+      </p:sp>
+      <p:sp>
+        <p:nvSpPr>
+          <p:cNvPr id="3" name="Rectangle 1">
+            <a:extLst>
+              <a:ext uri="{FF2B5EF4-FFF2-40B4-BE49-F238E27FC236}">
+                <a16:creationId xmlns:a16="http://schemas.microsoft.com/office/drawing/2014/main" id="{51316B3F-D829-3B85-008F-FE603F7CC0A8}"/>
+              </a:ext>
+            </a:extLst>
+          </p:cNvPr>
+          <p:cNvSpPr>
+            <a:spLocks noChangeArrowheads="1"/>
+          </p:cNvSpPr>
+          <p:nvPr/>
+        </p:nvSpPr>
+        <p:spPr bwMode="auto">
+          <a:xfrm>
+            <a:off x="2095500" y="1574048"/>
+            <a:ext cx="8001000" cy="4893647"/>
+          </a:xfrm>
+          <a:prstGeom prst="rect">
+            <a:avLst/>
+          </a:prstGeom>
+          <a:gradFill>
+            <a:gsLst>
+              <a:gs pos="0">
+                <a:schemeClr val="accent1">
+                  <a:tint val="50000"/>
+                  <a:satMod val="300000"/>
+                </a:schemeClr>
+              </a:gs>
+              <a:gs pos="35000">
+                <a:schemeClr val="accent1">
+                  <a:tint val="37000"/>
+                  <a:satMod val="300000"/>
+                </a:schemeClr>
+              </a:gs>
+              <a:gs pos="100000">
+                <a:schemeClr val="accent1">
+                  <a:tint val="15000"/>
+                  <a:satMod val="350000"/>
+                </a:schemeClr>
+              </a:gs>
+            </a:gsLst>
+            <a:lin ang="16200000" scaled="1"/>
+          </a:gradFill>
+          <a:ln/>
+        </p:spPr>
+        <p:style>
+          <a:lnRef idx="2">
+            <a:schemeClr val="accent4"/>
+          </a:lnRef>
+          <a:fillRef idx="1">
+            <a:schemeClr val="lt1"/>
+          </a:fillRef>
+          <a:effectRef idx="0">
+            <a:schemeClr val="accent4"/>
+          </a:effectRef>
+          <a:fontRef idx="minor">
+            <a:schemeClr val="dk1"/>
+          </a:fontRef>
+        </p:style>
+        <p:txBody>
+          <a:bodyPr vert="horz" wrap="square" lIns="91440" tIns="45720" rIns="91440" bIns="45720" numCol="1" anchor="ctr" anchorCtr="0" compatLnSpc="1">
+            <a:prstTxWarp prst="textNoShape">
+              <a:avLst/>
+            </a:prstTxWarp>
+            <a:spAutoFit/>
+          </a:bodyPr>
+          <a:lstStyle/>
+          <a:p>
+            <a:pPr eaLnBrk="0" fontAlgn="base" hangingPunct="0">
+              <a:spcBef>
+                <a:spcPct val="0"/>
+              </a:spcBef>
+              <a:spcAft>
+                <a:spcPct val="0"/>
+              </a:spcAft>
+            </a:pPr>
+            <a:r>
+              <a:rPr lang="en-IE" altLang="en-VI" sz="2400" dirty="0">
+                <a:solidFill>
+                  <a:srgbClr val="0033B3"/>
+                </a:solidFill>
+                <a:latin typeface="JetBrains Mono"/>
+              </a:rPr>
+              <a:t> public </a:t>
+            </a:r>
+            <a:r>
+              <a:rPr lang="en-IE" altLang="en-VI" sz="2400" dirty="0">
+                <a:solidFill>
+                  <a:schemeClr val="tx1"/>
+                </a:solidFill>
+                <a:latin typeface="JetBrains Mono"/>
+              </a:rPr>
+              <a:t>String</a:t>
+            </a:r>
+            <a:r>
+              <a:rPr lang="en-IE" altLang="en-VI" sz="2400" dirty="0">
+                <a:solidFill>
+                  <a:srgbClr val="0033B3"/>
+                </a:solidFill>
+                <a:latin typeface="JetBrains Mono"/>
+              </a:rPr>
+              <a:t> </a:t>
+            </a:r>
+            <a:r>
+              <a:rPr lang="en-IE" altLang="en-VI" sz="2400" dirty="0" err="1">
+                <a:solidFill>
+                  <a:srgbClr val="0033B3"/>
+                </a:solidFill>
+                <a:latin typeface="JetBrains Mono"/>
+              </a:rPr>
+              <a:t>l</a:t>
+            </a:r>
+            <a:r>
+              <a:rPr lang="en-IE" altLang="en-VI" sz="2400" dirty="0" err="1">
+                <a:solidFill>
+                  <a:srgbClr val="00627A"/>
+                </a:solidFill>
+                <a:latin typeface="JetBrains Mono"/>
+              </a:rPr>
+              <a:t>istOfFriends</a:t>
+            </a:r>
+            <a:r>
+              <a:rPr lang="en-IE" altLang="en-VI" sz="2400" dirty="0">
+                <a:solidFill>
+                  <a:srgbClr val="00627A"/>
+                </a:solidFill>
+                <a:latin typeface="JetBrains Mono"/>
+              </a:rPr>
+              <a:t>(</a:t>
+            </a:r>
+            <a:r>
+              <a:rPr lang="en-IE" altLang="en-VI" sz="2400" dirty="0">
+                <a:solidFill>
+                  <a:srgbClr val="0033B3"/>
+                </a:solidFill>
+                <a:latin typeface="JetBrains Mono"/>
+              </a:rPr>
+              <a:t>){</a:t>
+            </a:r>
+          </a:p>
+          <a:p>
+            <a:pPr eaLnBrk="0" fontAlgn="base" hangingPunct="0">
+              <a:spcBef>
+                <a:spcPct val="0"/>
+              </a:spcBef>
+              <a:spcAft>
+                <a:spcPct val="0"/>
+              </a:spcAft>
+            </a:pPr>
+            <a:endParaRPr lang="en-IE" altLang="en-VI" sz="2400" dirty="0">
+              <a:solidFill>
+                <a:schemeClr val="tx1"/>
+              </a:solidFill>
+              <a:latin typeface="JetBrains Mono"/>
+            </a:endParaRPr>
+          </a:p>
+          <a:p>
+            <a:pPr eaLnBrk="0" fontAlgn="base" hangingPunct="0">
+              <a:spcBef>
+                <a:spcPct val="0"/>
+              </a:spcBef>
+              <a:spcAft>
+                <a:spcPct val="0"/>
+              </a:spcAft>
+            </a:pPr>
+            <a:r>
+              <a:rPr lang="en-IE" altLang="en-VI" sz="2400" dirty="0">
+                <a:solidFill>
+                  <a:schemeClr val="tx1"/>
+                </a:solidFill>
+                <a:latin typeface="JetBrains Mono"/>
+              </a:rPr>
+              <a:t>          String </a:t>
+            </a:r>
+            <a:r>
+              <a:rPr lang="en-IE" altLang="en-VI" sz="2400" dirty="0" err="1">
+                <a:solidFill>
+                  <a:schemeClr val="tx1"/>
+                </a:solidFill>
+                <a:latin typeface="JetBrains Mono"/>
+              </a:rPr>
+              <a:t>listOfStudents</a:t>
+            </a:r>
+            <a:r>
+              <a:rPr lang="en-IE" altLang="en-VI" sz="2400" dirty="0">
+                <a:solidFill>
+                  <a:schemeClr val="tx1"/>
+                </a:solidFill>
+                <a:latin typeface="JetBrains Mono"/>
+              </a:rPr>
+              <a:t> = "List of friends \n";</a:t>
+            </a:r>
+          </a:p>
+          <a:p>
+            <a:pPr eaLnBrk="0" fontAlgn="base" hangingPunct="0">
+              <a:spcBef>
+                <a:spcPct val="0"/>
+              </a:spcBef>
+              <a:spcAft>
+                <a:spcPct val="0"/>
+              </a:spcAft>
+            </a:pPr>
+            <a:endParaRPr lang="en-IE" altLang="en-VI" sz="2400" dirty="0">
+              <a:solidFill>
+                <a:schemeClr val="tx1"/>
+              </a:solidFill>
+              <a:latin typeface="JetBrains Mono"/>
+            </a:endParaRPr>
+          </a:p>
+          <a:p>
+            <a:pPr eaLnBrk="0" fontAlgn="base" hangingPunct="0">
+              <a:spcBef>
+                <a:spcPct val="0"/>
+              </a:spcBef>
+              <a:spcAft>
+                <a:spcPct val="0"/>
+              </a:spcAft>
+            </a:pPr>
+            <a:r>
+              <a:rPr lang="en-029" altLang="en-VI" sz="2400" dirty="0">
+                <a:solidFill>
+                  <a:srgbClr val="080808"/>
+                </a:solidFill>
+                <a:latin typeface="JetBrains Mono"/>
+              </a:rPr>
+              <a:t>          </a:t>
+            </a:r>
+            <a:r>
+              <a:rPr lang="en-VI" altLang="en-VI" sz="2400" dirty="0">
+                <a:solidFill>
+                  <a:srgbClr val="080808"/>
+                </a:solidFill>
+                <a:latin typeface="JetBrains Mono"/>
+              </a:rPr>
+              <a:t> </a:t>
+            </a:r>
+            <a:r>
+              <a:rPr lang="en-VI" altLang="en-VI" sz="2400" dirty="0">
+                <a:solidFill>
+                  <a:srgbClr val="0033B3"/>
+                </a:solidFill>
+                <a:latin typeface="JetBrains Mono"/>
+              </a:rPr>
+              <a:t>for </a:t>
+            </a:r>
+            <a:r>
+              <a:rPr lang="en-VI" altLang="en-VI" sz="2400" dirty="0">
+                <a:solidFill>
+                  <a:srgbClr val="080808"/>
+                </a:solidFill>
+                <a:latin typeface="JetBrains Mono"/>
+              </a:rPr>
+              <a:t>(</a:t>
+            </a:r>
+            <a:r>
+              <a:rPr lang="en-VI" altLang="en-VI" sz="2400" dirty="0">
+                <a:solidFill>
+                  <a:srgbClr val="0033B3"/>
+                </a:solidFill>
+                <a:latin typeface="JetBrains Mono"/>
+              </a:rPr>
+              <a:t>int </a:t>
+            </a:r>
+            <a:r>
+              <a:rPr lang="en-VI" altLang="en-VI" sz="2400" dirty="0" err="1">
+                <a:solidFill>
+                  <a:srgbClr val="080808"/>
+                </a:solidFill>
+                <a:latin typeface="JetBrains Mono"/>
+              </a:rPr>
+              <a:t>i</a:t>
+            </a:r>
+            <a:r>
+              <a:rPr lang="en-VI" altLang="en-VI" sz="2400" dirty="0">
+                <a:solidFill>
+                  <a:srgbClr val="080808"/>
+                </a:solidFill>
+                <a:latin typeface="JetBrains Mono"/>
+              </a:rPr>
+              <a:t> = </a:t>
+            </a:r>
+            <a:r>
+              <a:rPr lang="en-VI" altLang="en-VI" sz="2400" dirty="0">
+                <a:solidFill>
+                  <a:srgbClr val="1750EB"/>
+                </a:solidFill>
+                <a:latin typeface="JetBrains Mono"/>
+              </a:rPr>
+              <a:t>0</a:t>
+            </a:r>
+            <a:r>
+              <a:rPr lang="en-VI" altLang="en-VI" sz="2400" dirty="0">
+                <a:solidFill>
+                  <a:srgbClr val="080808"/>
+                </a:solidFill>
+                <a:latin typeface="JetBrains Mono"/>
+              </a:rPr>
+              <a:t>; </a:t>
+            </a:r>
+            <a:r>
+              <a:rPr lang="en-VI" altLang="en-VI" sz="2400" dirty="0" err="1">
+                <a:solidFill>
+                  <a:srgbClr val="080808"/>
+                </a:solidFill>
+                <a:latin typeface="JetBrains Mono"/>
+              </a:rPr>
+              <a:t>i</a:t>
+            </a:r>
+            <a:r>
+              <a:rPr lang="en-VI" altLang="en-VI" sz="2400" dirty="0">
+                <a:solidFill>
+                  <a:srgbClr val="080808"/>
+                </a:solidFill>
+                <a:latin typeface="JetBrains Mono"/>
+              </a:rPr>
+              <a:t> &lt; </a:t>
+            </a:r>
+            <a:r>
+              <a:rPr lang="en-GB" altLang="en-VI" sz="2400" dirty="0" err="1">
+                <a:solidFill>
+                  <a:srgbClr val="871094"/>
+                </a:solidFill>
+                <a:latin typeface="JetBrains Mono"/>
+              </a:rPr>
+              <a:t>friends.length</a:t>
+            </a:r>
+            <a:r>
+              <a:rPr lang="en-VI" altLang="en-VI" sz="2400" dirty="0">
+                <a:solidFill>
+                  <a:srgbClr val="080808"/>
+                </a:solidFill>
+                <a:latin typeface="JetBrains Mono"/>
+              </a:rPr>
+              <a:t>; </a:t>
+            </a:r>
+            <a:r>
+              <a:rPr lang="en-VI" altLang="en-VI" sz="2400" dirty="0" err="1">
+                <a:solidFill>
+                  <a:srgbClr val="080808"/>
+                </a:solidFill>
+                <a:latin typeface="JetBrains Mono"/>
+              </a:rPr>
+              <a:t>i</a:t>
+            </a:r>
+            <a:r>
+              <a:rPr lang="en-VI" altLang="en-VI" sz="2400" dirty="0">
+                <a:solidFill>
+                  <a:srgbClr val="080808"/>
+                </a:solidFill>
+                <a:latin typeface="JetBrains Mono"/>
+              </a:rPr>
+              <a:t>++) {</a:t>
+            </a:r>
+            <a:endParaRPr lang="en-029" altLang="en-VI" sz="2400" dirty="0">
+              <a:solidFill>
+                <a:srgbClr val="080808"/>
+              </a:solidFill>
+              <a:latin typeface="JetBrains Mono"/>
+            </a:endParaRPr>
+          </a:p>
+          <a:p>
+            <a:pPr eaLnBrk="0" fontAlgn="base" hangingPunct="0">
+              <a:spcBef>
+                <a:spcPct val="0"/>
+              </a:spcBef>
+              <a:spcAft>
+                <a:spcPct val="0"/>
+              </a:spcAft>
+            </a:pPr>
+            <a:br>
+              <a:rPr lang="en-VI" altLang="en-VI" sz="2400" dirty="0">
+                <a:solidFill>
+                  <a:srgbClr val="080808"/>
+                </a:solidFill>
+                <a:latin typeface="JetBrains Mono"/>
+              </a:rPr>
+            </a:br>
+            <a:r>
+              <a:rPr lang="en-IE" altLang="en-VI" sz="2400" dirty="0">
+                <a:solidFill>
+                  <a:schemeClr val="tx1"/>
+                </a:solidFill>
+                <a:latin typeface="JetBrains Mono"/>
+              </a:rPr>
+              <a:t>                     </a:t>
+            </a:r>
+            <a:r>
+              <a:rPr lang="en-IE" altLang="en-VI" sz="2400" dirty="0" err="1">
+                <a:solidFill>
+                  <a:schemeClr val="tx1"/>
+                </a:solidFill>
+                <a:latin typeface="JetBrains Mono"/>
+              </a:rPr>
+              <a:t>listOfStudents</a:t>
+            </a:r>
+            <a:r>
+              <a:rPr lang="en-IE" altLang="en-VI" sz="2400" dirty="0">
+                <a:solidFill>
+                  <a:schemeClr val="tx1"/>
+                </a:solidFill>
+                <a:latin typeface="JetBrains Mono"/>
+              </a:rPr>
+              <a:t>  += friends[</a:t>
+            </a:r>
+            <a:r>
+              <a:rPr lang="en-IE" altLang="en-VI" sz="2400" dirty="0" err="1">
+                <a:solidFill>
+                  <a:schemeClr val="tx1"/>
+                </a:solidFill>
+                <a:latin typeface="JetBrains Mono"/>
+              </a:rPr>
+              <a:t>i</a:t>
+            </a:r>
+            <a:r>
+              <a:rPr lang="en-IE" altLang="en-VI" sz="2400" dirty="0">
+                <a:solidFill>
+                  <a:schemeClr val="tx1"/>
+                </a:solidFill>
+                <a:latin typeface="JetBrains Mono"/>
+              </a:rPr>
+              <a:t>].</a:t>
+            </a:r>
+            <a:r>
+              <a:rPr lang="en-IE" altLang="en-VI" sz="2400" dirty="0" err="1">
+                <a:solidFill>
+                  <a:schemeClr val="tx1"/>
+                </a:solidFill>
+                <a:latin typeface="JetBrains Mono"/>
+              </a:rPr>
+              <a:t>getFirstName</a:t>
+            </a:r>
+            <a:r>
+              <a:rPr lang="en-IE" altLang="en-VI" sz="2400" dirty="0">
+                <a:solidFill>
+                  <a:schemeClr val="tx1"/>
+                </a:solidFill>
+                <a:latin typeface="JetBrains Mono"/>
+              </a:rPr>
+              <a:t>() + "  " </a:t>
+            </a:r>
+          </a:p>
+          <a:p>
+            <a:pPr eaLnBrk="0" fontAlgn="base" hangingPunct="0">
+              <a:spcBef>
+                <a:spcPct val="0"/>
+              </a:spcBef>
+              <a:spcAft>
+                <a:spcPct val="0"/>
+              </a:spcAft>
+            </a:pPr>
+            <a:r>
+              <a:rPr lang="en-IE" altLang="en-VI" sz="2400" dirty="0">
+                <a:solidFill>
+                  <a:schemeClr val="tx1"/>
+                </a:solidFill>
+                <a:latin typeface="JetBrains Mono"/>
+              </a:rPr>
+              <a:t>		                     + friends[</a:t>
+            </a:r>
+            <a:r>
+              <a:rPr lang="en-IE" altLang="en-VI" sz="2400" dirty="0" err="1">
+                <a:solidFill>
+                  <a:schemeClr val="tx1"/>
+                </a:solidFill>
+                <a:latin typeface="JetBrains Mono"/>
+              </a:rPr>
+              <a:t>i</a:t>
+            </a:r>
+            <a:r>
+              <a:rPr lang="en-IE" altLang="en-VI" sz="2400" dirty="0">
+                <a:solidFill>
+                  <a:schemeClr val="tx1"/>
+                </a:solidFill>
+                <a:latin typeface="JetBrains Mono"/>
+              </a:rPr>
+              <a:t>].</a:t>
+            </a:r>
+            <a:r>
+              <a:rPr lang="en-IE" altLang="en-VI" sz="2400" dirty="0" err="1">
+                <a:solidFill>
+                  <a:schemeClr val="tx1"/>
+                </a:solidFill>
+                <a:latin typeface="JetBrains Mono"/>
+              </a:rPr>
+              <a:t>getSecondName</a:t>
+            </a:r>
+            <a:r>
+              <a:rPr lang="en-IE" altLang="en-VI" sz="2400" dirty="0">
+                <a:solidFill>
+                  <a:schemeClr val="tx1"/>
+                </a:solidFill>
+                <a:latin typeface="JetBrains Mono"/>
+              </a:rPr>
+              <a:t>() + "\n";</a:t>
+            </a:r>
+          </a:p>
+          <a:p>
+            <a:pPr eaLnBrk="0" fontAlgn="base" hangingPunct="0">
+              <a:spcBef>
+                <a:spcPct val="0"/>
+              </a:spcBef>
+              <a:spcAft>
+                <a:spcPct val="0"/>
+              </a:spcAft>
+            </a:pPr>
+            <a:r>
+              <a:rPr lang="en-IE" altLang="en-VI" sz="2400" dirty="0">
+                <a:solidFill>
+                  <a:schemeClr val="tx1"/>
+                </a:solidFill>
+                <a:latin typeface="JetBrains Mono"/>
+              </a:rPr>
+              <a:t>          </a:t>
+            </a:r>
+          </a:p>
+          <a:p>
+            <a:pPr eaLnBrk="0" fontAlgn="base" hangingPunct="0">
+              <a:spcBef>
+                <a:spcPct val="0"/>
+              </a:spcBef>
+              <a:spcAft>
+                <a:spcPct val="0"/>
+              </a:spcAft>
+            </a:pPr>
+            <a:r>
+              <a:rPr lang="en-IE" altLang="en-VI" sz="2400" dirty="0">
+                <a:solidFill>
+                  <a:schemeClr val="tx1"/>
+                </a:solidFill>
+                <a:latin typeface="JetBrains Mono"/>
+              </a:rPr>
+              <a:t>               </a:t>
+            </a:r>
+            <a:r>
+              <a:rPr lang="en-IE" altLang="en-VI" sz="2400" dirty="0">
+                <a:solidFill>
+                  <a:srgbClr val="0033B3"/>
+                </a:solidFill>
+                <a:latin typeface="JetBrains Mono"/>
+              </a:rPr>
+              <a:t>return</a:t>
+            </a:r>
+            <a:r>
+              <a:rPr lang="en-IE" altLang="en-VI" sz="2400" dirty="0">
+                <a:solidFill>
+                  <a:schemeClr val="tx1"/>
+                </a:solidFill>
+                <a:latin typeface="JetBrains Mono"/>
+              </a:rPr>
+              <a:t> </a:t>
+            </a:r>
+            <a:r>
+              <a:rPr lang="en-IE" altLang="en-VI" sz="2400" dirty="0" err="1">
+                <a:solidFill>
+                  <a:schemeClr val="tx1"/>
+                </a:solidFill>
+                <a:latin typeface="JetBrains Mono"/>
+              </a:rPr>
+              <a:t>listOfStudents</a:t>
+            </a:r>
+            <a:r>
+              <a:rPr lang="en-IE" altLang="en-VI" sz="2400" dirty="0">
+                <a:solidFill>
+                  <a:schemeClr val="tx1"/>
+                </a:solidFill>
+                <a:latin typeface="JetBrains Mono"/>
+              </a:rPr>
+              <a:t>;</a:t>
+            </a:r>
+          </a:p>
+          <a:p>
+            <a:pPr eaLnBrk="0" fontAlgn="base" hangingPunct="0">
+              <a:spcBef>
+                <a:spcPct val="0"/>
+              </a:spcBef>
+              <a:spcAft>
+                <a:spcPct val="0"/>
+              </a:spcAft>
+            </a:pPr>
+            <a:r>
+              <a:rPr lang="en-IE" altLang="en-VI" sz="2400" dirty="0">
+                <a:solidFill>
+                  <a:schemeClr val="tx1"/>
+                </a:solidFill>
+                <a:latin typeface="JetBrains Mono"/>
+              </a:rPr>
+              <a:t>       }</a:t>
+            </a:r>
+          </a:p>
+          <a:p>
+            <a:pPr eaLnBrk="0" fontAlgn="base" hangingPunct="0">
+              <a:spcBef>
+                <a:spcPct val="0"/>
+              </a:spcBef>
+              <a:spcAft>
+                <a:spcPct val="0"/>
+              </a:spcAft>
+            </a:pPr>
+            <a:r>
+              <a:rPr lang="en-IE" altLang="en-VI" sz="2400" dirty="0">
+                <a:solidFill>
+                  <a:schemeClr val="tx1"/>
+                </a:solidFill>
+                <a:latin typeface="JetBrains Mono"/>
+              </a:rPr>
+              <a:t>   }</a:t>
+            </a:r>
+          </a:p>
+          <a:p>
+            <a:pPr eaLnBrk="0" fontAlgn="base" hangingPunct="0">
+              <a:spcBef>
+                <a:spcPct val="0"/>
+              </a:spcBef>
+              <a:spcAft>
+                <a:spcPct val="0"/>
+              </a:spcAft>
+            </a:pPr>
+            <a:r>
+              <a:rPr lang="en-VI" altLang="en-VI" sz="2400" dirty="0">
+                <a:solidFill>
+                  <a:schemeClr val="tx1"/>
+                </a:solidFill>
+                <a:latin typeface="JetBrains Mono"/>
+              </a:rPr>
+              <a:t>}</a:t>
+            </a:r>
+          </a:p>
+        </p:txBody>
+      </p:sp>
+      <p:sp>
+        <p:nvSpPr>
+          <p:cNvPr id="7" name="TextBox 6">
+            <a:extLst>
+              <a:ext uri="{FF2B5EF4-FFF2-40B4-BE49-F238E27FC236}">
+                <a16:creationId xmlns:a16="http://schemas.microsoft.com/office/drawing/2014/main" id="{D5B75913-F634-8664-2524-0E44604C45EB}"/>
+              </a:ext>
+            </a:extLst>
+          </p:cNvPr>
+          <p:cNvSpPr txBox="1"/>
+          <p:nvPr/>
+        </p:nvSpPr>
+        <p:spPr>
+          <a:xfrm>
+            <a:off x="1984651" y="6457890"/>
             <a:ext cx="8346644" cy="400110"/>
           </a:xfrm>
           <a:prstGeom prst="rect">
@@ -25750,7 +26540,7 @@
     </p:spTree>
     <p:extLst>
       <p:ext uri="{BB962C8B-B14F-4D97-AF65-F5344CB8AC3E}">
-        <p14:creationId xmlns:p14="http://schemas.microsoft.com/office/powerpoint/2010/main" val="825745404"/>
+        <p14:creationId xmlns:p14="http://schemas.microsoft.com/office/powerpoint/2010/main" val="3075507651"/>
       </p:ext>
     </p:extLst>
   </p:cSld>
@@ -25760,7 +26550,7 @@
 </p:sld>
 </file>
 
-<file path=ppt/slides/slide27.xml><?xml version="1.0" encoding="utf-8"?>
+<file path=ppt/slides/slide28.xml><?xml version="1.0" encoding="utf-8"?>
 <p:sld xmlns:a="http://schemas.openxmlformats.org/drawingml/2006/main" xmlns:r="http://schemas.openxmlformats.org/officeDocument/2006/relationships" xmlns:p="http://schemas.openxmlformats.org/presentationml/2006/main">
   <p:cSld>
     <p:spTree>
@@ -30390,4 +31180,47 @@
   <a:objectDefaults/>
   <a:extraClrSchemeLst/>
 </a:theme>
+</file>
+
+<file path=ppt/theme/themeOverride1.xml><?xml version="1.0" encoding="utf-8"?>
+<a:themeOverride xmlns:a="http://schemas.openxmlformats.org/drawingml/2006/main">
+  <a:clrScheme name="Office">
+    <a:dk1>
+      <a:sysClr val="windowText" lastClr="000000"/>
+    </a:dk1>
+    <a:lt1>
+      <a:sysClr val="window" lastClr="FFFFFF"/>
+    </a:lt1>
+    <a:dk2>
+      <a:srgbClr val="1F497D"/>
+    </a:dk2>
+    <a:lt2>
+      <a:srgbClr val="EEECE1"/>
+    </a:lt2>
+    <a:accent1>
+      <a:srgbClr val="4F81BD"/>
+    </a:accent1>
+    <a:accent2>
+      <a:srgbClr val="C0504D"/>
+    </a:accent2>
+    <a:accent3>
+      <a:srgbClr val="9BBB59"/>
+    </a:accent3>
+    <a:accent4>
+      <a:srgbClr val="8064A2"/>
+    </a:accent4>
+    <a:accent5>
+      <a:srgbClr val="4BACC6"/>
+    </a:accent5>
+    <a:accent6>
+      <a:srgbClr val="F79646"/>
+    </a:accent6>
+    <a:hlink>
+      <a:srgbClr val="0000FF"/>
+    </a:hlink>
+    <a:folHlink>
+      <a:srgbClr val="800080"/>
+    </a:folHlink>
+  </a:clrScheme>
+</a:themeOverride>
 </file>
</xml_diff>

<commit_message>
update uml diagram for Person - add listString and printString
</commit_message>
<xml_diff>
--- a/topic06-arrays/unit-1/talk-2-array-classes/b-array-classes.pptx
+++ b/topic06-arrays/unit-1/talk-2-array-classes/b-array-classes.pptx
@@ -21772,10 +21772,10 @@
       </p:sp>
       <p:pic>
         <p:nvPicPr>
-          <p:cNvPr id="7" name="Picture 6">
+          <p:cNvPr id="8" name="Picture 7">
             <a:extLst>
               <a:ext uri="{FF2B5EF4-FFF2-40B4-BE49-F238E27FC236}">
-                <a16:creationId xmlns:a16="http://schemas.microsoft.com/office/drawing/2014/main" id="{BA288E3A-0485-A15B-D8F7-8972FDDA99A7}"/>
+                <a16:creationId xmlns:a16="http://schemas.microsoft.com/office/drawing/2014/main" id="{61CD5B0A-E36A-F080-A79F-67276BF92753}"/>
               </a:ext>
             </a:extLst>
           </p:cNvPr>
@@ -21792,8 +21792,8 @@
         </p:blipFill>
         <p:spPr>
           <a:xfrm>
-            <a:off x="6128307" y="1391473"/>
-            <a:ext cx="5422900" cy="5080000"/>
+            <a:off x="6324600" y="1705054"/>
+            <a:ext cx="4203700" cy="4749800"/>
           </a:xfrm>
           <a:prstGeom prst="rect">
             <a:avLst/>

</xml_diff>